<commit_message>
Switch paper demo to eight-word -ate/-at vocab with clearer DFA clustering.
Drop the Minimal-DFA panel from the PCA/separation composite, regenerate demo figures and slides from eight_word_ate_at_demo_ns, and keep the ake/ate-chain probes as exploratory runs.

Co-authored-by: Cursor <cursoragent@cursor.com>
</commit_message>
<xml_diff>
--- a/paper/slides/paper_figures.pptx
+++ b/paper/slides/paper_figures.pptx
@@ -4236,8 +4236,8 @@
         </p:blipFill>
         <p:spPr>
           <a:xfrm>
-            <a:off x="182880" y="1250072"/>
-            <a:ext cx="11825935" cy="5089375"/>
+            <a:off x="182880" y="920635"/>
+            <a:ext cx="11825935" cy="5748249"/>
           </a:xfrm>
           <a:prstGeom prst="rect">
             <a:avLst/>
@@ -4382,8 +4382,8 @@
         </p:blipFill>
         <p:spPr>
           <a:xfrm>
-            <a:off x="182880" y="1305400"/>
-            <a:ext cx="11825935" cy="4978718"/>
+            <a:off x="182880" y="1293574"/>
+            <a:ext cx="11825935" cy="5002370"/>
           </a:xfrm>
           <a:prstGeom prst="rect">
             <a:avLst/>
@@ -4455,8 +4455,8 @@
         </p:blipFill>
         <p:spPr>
           <a:xfrm>
-            <a:off x="2624815" y="868680"/>
-            <a:ext cx="6942064" cy="5852160"/>
+            <a:off x="2245742" y="868680"/>
+            <a:ext cx="7700210" cy="5852160"/>
           </a:xfrm>
           <a:prstGeom prst="rect">
             <a:avLst/>
@@ -4528,8 +4528,8 @@
         </p:blipFill>
         <p:spPr>
           <a:xfrm>
-            <a:off x="4019386" y="868680"/>
-            <a:ext cx="4152922" cy="5852160"/>
+            <a:off x="3068868" y="868680"/>
+            <a:ext cx="6053958" cy="5852160"/>
           </a:xfrm>
           <a:prstGeom prst="rect">
             <a:avLst/>

</xml_diff>

<commit_message>
Add DFA-colored CE/word-error curves to Fig 12 and Dale E/I motifs to Fig 19.
Scaling overview now overlays per-run learning curves with the PC-spectra color scale; weight-graph panels expand to typed dyad/triple motifs with refreshed metrics and paper sync.

Co-authored-by: Cursor <cursoragent@cursor.com>
</commit_message>
<xml_diff>
--- a/paper/slides/paper_figures.pptx
+++ b/paper/slides/paper_figures.pptx
@@ -4017,8 +4017,8 @@
         </p:blipFill>
         <p:spPr>
           <a:xfrm>
-            <a:off x="1388195" y="822960"/>
-            <a:ext cx="6367608" cy="4166235"/>
+            <a:off x="3268888" y="822960"/>
+            <a:ext cx="2606223" cy="4166235"/>
           </a:xfrm>
           <a:prstGeom prst="rect">
             <a:avLst/>
@@ -4236,8 +4236,8 @@
         </p:blipFill>
         <p:spPr>
           <a:xfrm>
-            <a:off x="286379" y="822960"/>
-            <a:ext cx="8571240" cy="4166234"/>
+            <a:off x="182880" y="1907552"/>
+            <a:ext cx="8778240" cy="1997049"/>
           </a:xfrm>
           <a:prstGeom prst="rect">
             <a:avLst/>
@@ -4309,8 +4309,8 @@
         </p:blipFill>
         <p:spPr>
           <a:xfrm>
-            <a:off x="1485900" y="822960"/>
-            <a:ext cx="6172200" cy="4166235"/>
+            <a:off x="2043944" y="822960"/>
+            <a:ext cx="5056110" cy="4166235"/>
           </a:xfrm>
           <a:prstGeom prst="rect">
             <a:avLst/>
@@ -4382,8 +4382,8 @@
         </p:blipFill>
         <p:spPr>
           <a:xfrm>
-            <a:off x="182880" y="1049479"/>
-            <a:ext cx="8778240" cy="3713195"/>
+            <a:off x="487455" y="822960"/>
+            <a:ext cx="8169088" cy="4166235"/>
           </a:xfrm>
           <a:prstGeom prst="rect">
             <a:avLst/>
@@ -4455,8 +4455,8 @@
         </p:blipFill>
         <p:spPr>
           <a:xfrm>
-            <a:off x="1831055" y="822960"/>
-            <a:ext cx="5481888" cy="4166235"/>
+            <a:off x="2559326" y="822960"/>
+            <a:ext cx="4025347" cy="4166235"/>
           </a:xfrm>
           <a:prstGeom prst="rect">
             <a:avLst/>

</xml_diff>